<commit_message>
fix late fusion results across report, presentation, and README
Reconcile all reported numbers with the final late_fusion.ipynb run:
best alpha_text=0.45 (not 0.60), Macro F1=0.7108, text/audio baseline
scores, per-class breakdowns, consensus tiers, and corrected-GT table.
Also removes the stale data-leakage caveat and fills in previously
unpopulated TODO tables in docs/report.md.

Co-Authored-By: Claude Sonnet 4.6 <noreply@anthropic.com>
</commit_message>
<xml_diff>
--- a/docs/Final_Presentation.pptx
+++ b/docs/Final_Presentation.pptx
@@ -5121,7 +5121,7 @@
                 </a:solidFill>
                 <a:latin typeface="Calibri"/>
               </a:rPr>
-              <a:t>Late Fusion: a weighted sum of output logits — no extra training needed</a:t>
+              <a:t>Late Fusion: a weighted sum of output logits - no extra training needed</a:t>
             </a:r>
           </a:p>
         </p:txBody>
@@ -5710,7 +5710,7 @@
                 </a:solidFill>
                 <a:latin typeface="Calibri"/>
               </a:rPr>
-              <a:t>One parameter α — found by systematic grid search from 0.0 to 1.0 (step 0.05)</a:t>
+              <a:t>One parameter α - found by systematic grid search from 0.0 to 1.0 (step 0.05)</a:t>
             </a:r>
           </a:p>
         </p:txBody>
@@ -5920,7 +5920,7 @@
                 </a:solidFill>
                 <a:latin typeface="Calibri"/>
               </a:rPr>
-              <a:t>The weight search shows text matters more — but both channels are essential</a:t>
+              <a:t>The weight search shows text matters more - but both channels are essential</a:t>
             </a:r>
           </a:p>
         </p:txBody>
@@ -6038,30 +6038,6 @@
           </a:p>
         </p:txBody>
       </p:sp>
-      <p:pic>
-        <p:nvPicPr>
-          <p:cNvPr id="7" name="Picture 6" descr="fig_weight_search_crop.png"/>
-          <p:cNvPicPr>
-            <a:picLocks noChangeAspect="1"/>
-          </p:cNvPicPr>
-          <p:nvPr/>
-        </p:nvPicPr>
-        <p:blipFill>
-          <a:blip r:embed="rId2"/>
-          <a:stretch>
-            <a:fillRect/>
-          </a:stretch>
-        </p:blipFill>
-        <p:spPr>
-          <a:xfrm>
-            <a:off x="3506724" y="1293876"/>
-            <a:ext cx="5174278" cy="3429000"/>
-          </a:xfrm>
-          <a:prstGeom prst="rect">
-            <a:avLst/>
-          </a:prstGeom>
-        </p:spPr>
-      </p:pic>
       <p:sp>
         <p:nvSpPr>
           <p:cNvPr id="8" name="Rectangle 7"/>
@@ -6111,8 +6087,8 @@
                 </a:solidFill>
                 <a:latin typeface="Calibri"/>
               </a:rPr>
-              <a:t>Best α = 0.60
-Text 60% · Audio 40%</a:t>
+              <a:t>Best α = 0.45
+Text 45% · Audio 55%</a:t>
             </a:r>
           </a:p>
         </p:txBody>
@@ -6167,7 +6143,7 @@
                 <a:latin typeface="Calibri"/>
               </a:rPr>
               <a:t>Plateau region
-Robust for α ∈ [0.5, 0.7]</a:t>
+Robust for α ∈ [0.35, 0.55]</a:t>
             </a:r>
           </a:p>
         </p:txBody>
@@ -6222,7 +6198,7 @@
                 <a:latin typeface="Calibri"/>
               </a:rPr>
               <a:t>Sanity check ✓
-α=0→0.6403  α=1→0.6519</a:t>
+α=0→0.6398  α=1→0.6475</a:t>
             </a:r>
           </a:p>
         </p:txBody>
@@ -6274,11 +6250,35 @@
                 </a:solidFill>
                 <a:latin typeface="Calibri"/>
               </a:rPr>
-              <a:t>Best α = 0.60  →  Macro F1 = 0.7104  (+0.059 over text-only, +0.070 over audio-only)</a:t>
-            </a:r>
-          </a:p>
-        </p:txBody>
-      </p:sp>
+              <a:t>Best α = 0.45  →  Macro F1 = 0.7108  (+0.063 over text-only, +0.071 over audio-only)</a:t>
+            </a:r>
+          </a:p>
+        </p:txBody>
+      </p:sp>
+      <p:pic>
+        <p:nvPicPr>
+          <p:cNvPr id="12" name="Picture 11" descr="slide11_new.png"/>
+          <p:cNvPicPr>
+            <a:picLocks noChangeAspect="1"/>
+          </p:cNvPicPr>
+          <p:nvPr/>
+        </p:nvPicPr>
+        <p:blipFill>
+          <a:blip r:embed="rId4"/>
+          <a:stretch>
+            <a:fillRect/>
+          </a:stretch>
+        </p:blipFill>
+        <p:spPr>
+          <a:xfrm>
+            <a:off x="3506724" y="1293876"/>
+            <a:ext cx="5174278" cy="3424879"/>
+          </a:xfrm>
+          <a:prstGeom prst="rect">
+            <a:avLst/>
+          </a:prstGeom>
+        </p:spPr>
+      </p:pic>
     </p:spTree>
   </p:cSld>
   <p:clrMapOvr>
@@ -6378,7 +6378,7 @@
                 </a:solidFill>
                 <a:latin typeface="Calibri"/>
               </a:rPr>
-              <a:t>Fusion achieves Macro F1 = 0.71 — a +0.06 improvement over text-only</a:t>
+              <a:t>Fusion achieves Macro F1 = 0.71 - a +0.06 improvement over text-only</a:t>
             </a:r>
           </a:p>
         </p:txBody>
@@ -6496,30 +6496,6 @@
           </a:p>
         </p:txBody>
       </p:sp>
-      <p:pic>
-        <p:nvPicPr>
-          <p:cNvPr id="7" name="Picture 6" descr="main_results.png"/>
-          <p:cNvPicPr>
-            <a:picLocks noChangeAspect="1"/>
-          </p:cNvPicPr>
-          <p:nvPr/>
-        </p:nvPicPr>
-        <p:blipFill>
-          <a:blip r:embed="rId2"/>
-          <a:stretch>
-            <a:fillRect/>
-          </a:stretch>
-        </p:blipFill>
-        <p:spPr>
-          <a:xfrm>
-            <a:off x="457200" y="1293876"/>
-            <a:ext cx="6196851" cy="3931920"/>
-          </a:xfrm>
-          <a:prstGeom prst="rect">
-            <a:avLst/>
-          </a:prstGeom>
-        </p:spPr>
-      </p:pic>
       <p:sp>
         <p:nvSpPr>
           <p:cNvPr id="8" name="TextBox 7"/>
@@ -6550,7 +6526,7 @@
                 </a:solidFill>
                 <a:latin typeface="Calibri"/>
               </a:rPr>
-              <a:t>0.7104</a:t>
+              <a:t>0.7108</a:t>
             </a:r>
           </a:p>
         </p:txBody>
@@ -6745,7 +6721,7 @@
                           </a:solidFill>
                           <a:latin typeface="Calibri"/>
                         </a:rPr>
-                        <a:t>0.6793</a:t>
+                        <a:t>0.6843</a:t>
                       </a:r>
                     </a:p>
                   </a:txBody>
@@ -6768,7 +6744,7 @@
                           </a:solidFill>
                           <a:latin typeface="Calibri"/>
                         </a:rPr>
-                        <a:t>0.6519</a:t>
+                        <a:t>0.6475</a:t>
                       </a:r>
                     </a:p>
                   </a:txBody>
@@ -6791,7 +6767,7 @@
                           </a:solidFill>
                           <a:latin typeface="Calibri"/>
                         </a:rPr>
-                        <a:t>0.6948</a:t>
+                        <a:t>0.6937</a:t>
                       </a:r>
                     </a:p>
                   </a:txBody>
@@ -6839,7 +6815,7 @@
                           </a:solidFill>
                           <a:latin typeface="Calibri"/>
                         </a:rPr>
-                        <a:t>0.6880</a:t>
+                        <a:t>0.6829</a:t>
                       </a:r>
                     </a:p>
                   </a:txBody>
@@ -6862,7 +6838,7 @@
                           </a:solidFill>
                           <a:latin typeface="Calibri"/>
                         </a:rPr>
-                        <a:t>0.6403</a:t>
+                        <a:t>0.6398</a:t>
                       </a:r>
                     </a:p>
                   </a:txBody>
@@ -6885,7 +6861,7 @@
                           </a:solidFill>
                           <a:latin typeface="Calibri"/>
                         </a:rPr>
-                        <a:t>0.6874</a:t>
+                        <a:t>0.6876</a:t>
                       </a:r>
                     </a:p>
                   </a:txBody>
@@ -6933,7 +6909,7 @@
                           </a:solidFill>
                           <a:latin typeface="Calibri"/>
                         </a:rPr>
-                        <a:t>—</a:t>
+                        <a:t>0.7502</a:t>
                       </a:r>
                     </a:p>
                   </a:txBody>
@@ -6956,7 +6932,7 @@
                           </a:solidFill>
                           <a:latin typeface="Calibri"/>
                         </a:rPr>
-                        <a:t>0.7104</a:t>
+                        <a:t>0.7108</a:t>
                       </a:r>
                     </a:p>
                   </a:txBody>
@@ -6979,7 +6955,7 @@
                           </a:solidFill>
                           <a:latin typeface="Calibri"/>
                         </a:rPr>
-                        <a:t>—</a:t>
+                        <a:t>0.7541</a:t>
                       </a:r>
                     </a:p>
                   </a:txBody>
@@ -7076,11 +7052,35 @@
                 </a:solidFill>
                 <a:latin typeface="Calibri"/>
               </a:rPr>
-              <a:t>+0.059 Macro F1 over text-only · No additional training · Fully speaker-independent</a:t>
-            </a:r>
-          </a:p>
-        </p:txBody>
-      </p:sp>
+              <a:t>+0.063 Macro F1 over text-only · No additional training · Fully speaker-independent</a:t>
+            </a:r>
+          </a:p>
+        </p:txBody>
+      </p:sp>
+      <p:pic>
+        <p:nvPicPr>
+          <p:cNvPr id="13" name="Picture 12" descr="slide12_new.png"/>
+          <p:cNvPicPr>
+            <a:picLocks noChangeAspect="1"/>
+          </p:cNvPicPr>
+          <p:nvPr/>
+        </p:nvPicPr>
+        <p:blipFill>
+          <a:blip r:embed="rId4"/>
+          <a:stretch>
+            <a:fillRect/>
+          </a:stretch>
+        </p:blipFill>
+        <p:spPr>
+          <a:xfrm>
+            <a:off x="457200" y="1293876"/>
+            <a:ext cx="6196851" cy="3936822"/>
+          </a:xfrm>
+          <a:prstGeom prst="rect">
+            <a:avLst/>
+          </a:prstGeom>
+        </p:spPr>
+      </p:pic>
     </p:spTree>
   </p:cSld>
   <p:clrMapOvr>
@@ -7180,7 +7180,7 @@
                 </a:solidFill>
                 <a:latin typeface="Calibri"/>
               </a:rPr>
-              <a:t>Neutral was the hardest class — fusion helped it most</a:t>
+              <a:t>Neutral was the hardest class - fusion helped it most</a:t>
             </a:r>
           </a:p>
         </p:txBody>
@@ -7298,30 +7298,6 @@
           </a:p>
         </p:txBody>
       </p:sp>
-      <p:pic>
-        <p:nvPicPr>
-          <p:cNvPr id="7" name="Picture 6" descr="perclass_comp.png"/>
-          <p:cNvPicPr>
-            <a:picLocks noChangeAspect="1"/>
-          </p:cNvPicPr>
-          <p:nvPr/>
-        </p:nvPicPr>
-        <p:blipFill>
-          <a:blip r:embed="rId2"/>
-          <a:stretch>
-            <a:fillRect/>
-          </a:stretch>
-        </p:blipFill>
-        <p:spPr>
-          <a:xfrm>
-            <a:off x="457200" y="1293876"/>
-            <a:ext cx="6937641" cy="3840480"/>
-          </a:xfrm>
-          <a:prstGeom prst="rect">
-            <a:avLst/>
-          </a:prstGeom>
-        </p:spPr>
-      </p:pic>
       <p:sp>
         <p:nvSpPr>
           <p:cNvPr id="8" name="Rectangle 7"/>
@@ -7383,7 +7359,7 @@
                 </a:solidFill>
                 <a:latin typeface="Calibri"/>
               </a:rPr>
-              <a:t>0.76 → 0.81</a:t>
+              <a:t>0.76 → 0.82</a:t>
             </a:r>
           </a:p>
           <a:p>
@@ -7461,7 +7437,7 @@
                 </a:solidFill>
                 <a:latin typeface="Calibri"/>
               </a:rPr>
-              <a:t>0.71 → 0.75</a:t>
+              <a:t>0.72 → 0.76</a:t>
             </a:r>
           </a:p>
           <a:p>
@@ -7473,7 +7449,7 @@
                 </a:solidFill>
                 <a:latin typeface="Calibri"/>
               </a:rPr>
-              <a:t>text 0.71  ·  audio 0.63</a:t>
+              <a:t>text 0.72  ·  audio 0.63</a:t>
             </a:r>
           </a:p>
         </p:txBody>
@@ -7527,7 +7503,7 @@
                 </a:solidFill>
                 <a:latin typeface="Calibri"/>
               </a:rPr>
-              <a:t>Neutral  ★ +0.07</a:t>
+              <a:t>Neutral  ★ +0.09</a:t>
             </a:r>
           </a:p>
           <a:p>
@@ -7539,7 +7515,7 @@
                 </a:solidFill>
                 <a:latin typeface="Calibri"/>
               </a:rPr>
-              <a:t>0.48 → 0.55</a:t>
+              <a:t>0.46 → 0.55</a:t>
             </a:r>
           </a:p>
           <a:p>
@@ -7551,7 +7527,7 @@
                 </a:solidFill>
                 <a:latin typeface="Calibri"/>
               </a:rPr>
-              <a:t>text 0.48  ·  audio 0.51</a:t>
+              <a:t>text 0.46  ·  audio 0.51</a:t>
             </a:r>
           </a:p>
         </p:txBody>
@@ -7608,6 +7584,30 @@
           </a:p>
         </p:txBody>
       </p:sp>
+      <p:pic>
+        <p:nvPicPr>
+          <p:cNvPr id="12" name="Picture 11" descr="slide13_new.png"/>
+          <p:cNvPicPr>
+            <a:picLocks noChangeAspect="1"/>
+          </p:cNvPicPr>
+          <p:nvPr/>
+        </p:nvPicPr>
+        <p:blipFill>
+          <a:blip r:embed="rId4"/>
+          <a:stretch>
+            <a:fillRect/>
+          </a:stretch>
+        </p:blipFill>
+        <p:spPr>
+          <a:xfrm>
+            <a:off x="457200" y="1293876"/>
+            <a:ext cx="6937641" cy="3854245"/>
+          </a:xfrm>
+          <a:prstGeom prst="rect">
+            <a:avLst/>
+          </a:prstGeom>
+        </p:spPr>
+      </p:pic>
     </p:spTree>
   </p:cSld>
   <p:clrMapOvr>
@@ -7855,7 +7855,7 @@
                 </a:solidFill>
                 <a:latin typeface="Calibri"/>
               </a:rPr>
-              <a:t>Part A — Re-scored against corrected labels (Sum-then-Argmax)</a:t>
+              <a:t>Part A - Re-scored against corrected labels (Sum-then-Argmax)</a:t>
             </a:r>
           </a:p>
         </p:txBody>
@@ -7890,7 +7890,7 @@
                 </a:solidFill>
                 <a:latin typeface="Calibri"/>
               </a:rPr>
-              <a:t>Only 4.24% of test labels changed (92 / 2,170). Δ across all models ≈ −0.004 — essentially zero.</a:t>
+              <a:t>Only 4.24% of test labels changed (92 / 2,170). Δ across all models is below 0.005 in magnitude - essentially zero.</a:t>
             </a:r>
           </a:p>
         </p:txBody>
@@ -8050,7 +8050,7 @@
                           </a:solidFill>
                           <a:latin typeface="Calibri"/>
                         </a:rPr>
-                        <a:t>0.6519</a:t>
+                        <a:t>0.6475</a:t>
                       </a:r>
                     </a:p>
                   </a:txBody>
@@ -8073,7 +8073,7 @@
                           </a:solidFill>
                           <a:latin typeface="Calibri"/>
                         </a:rPr>
-                        <a:t>0.6481</a:t>
+                        <a:t>0.6506</a:t>
                       </a:r>
                     </a:p>
                   </a:txBody>
@@ -8096,7 +8096,7 @@
                           </a:solidFill>
                           <a:latin typeface="Calibri"/>
                         </a:rPr>
-                        <a:t>−0.004</a:t>
+                        <a:t>+0.003</a:t>
                       </a:r>
                     </a:p>
                   </a:txBody>
@@ -8144,7 +8144,7 @@
                           </a:solidFill>
                           <a:latin typeface="Calibri"/>
                         </a:rPr>
-                        <a:t>0.6403</a:t>
+                        <a:t>0.6398</a:t>
                       </a:r>
                     </a:p>
                   </a:txBody>
@@ -8167,7 +8167,7 @@
                           </a:solidFill>
                           <a:latin typeface="Calibri"/>
                         </a:rPr>
-                        <a:t>0.6356</a:t>
+                        <a:t>0.6359</a:t>
                       </a:r>
                     </a:p>
                   </a:txBody>
@@ -8238,7 +8238,7 @@
                           </a:solidFill>
                           <a:latin typeface="Calibri"/>
                         </a:rPr>
-                        <a:t>0.7041</a:t>
+                        <a:t>0.7108</a:t>
                       </a:r>
                     </a:p>
                   </a:txBody>
@@ -8261,7 +8261,7 @@
                           </a:solidFill>
                           <a:latin typeface="Calibri"/>
                         </a:rPr>
-                        <a:t>0.6999</a:t>
+                        <a:t>0.7081</a:t>
                       </a:r>
                     </a:p>
                   </a:txBody>
@@ -8284,7 +8284,7 @@
                           </a:solidFill>
                           <a:latin typeface="Calibri"/>
                         </a:rPr>
-                        <a:t>−0.004</a:t>
+                        <a:t>−0.003</a:t>
                       </a:r>
                     </a:p>
                   </a:txBody>
@@ -8329,7 +8329,7 @@
                 </a:solidFill>
                 <a:latin typeface="Calibri"/>
               </a:rPr>
-              <a:t>Part B — Performance by human annotator agreement tier</a:t>
+              <a:t>Part B - Performance by human annotator agreement tier</a:t>
             </a:r>
           </a:p>
         </p:txBody>
@@ -8536,7 +8536,7 @@
                           </a:solidFill>
                           <a:latin typeface="Calibri"/>
                         </a:rPr>
-                        <a:t>0.233</a:t>
+                        <a:t>0.285</a:t>
                       </a:r>
                     </a:p>
                   </a:txBody>
@@ -8559,7 +8559,7 @@
                           </a:solidFill>
                           <a:latin typeface="Calibri"/>
                         </a:rPr>
-                        <a:t>0.363</a:t>
+                        <a:t>0.308</a:t>
                       </a:r>
                     </a:p>
                   </a:txBody>
@@ -8582,7 +8582,7 @@
                           </a:solidFill>
                           <a:latin typeface="Calibri"/>
                         </a:rPr>
-                        <a:t>0.318</a:t>
+                        <a:t>0.344</a:t>
                       </a:r>
                     </a:p>
                   </a:txBody>
@@ -8653,7 +8653,7 @@
                           </a:solidFill>
                           <a:latin typeface="Calibri"/>
                         </a:rPr>
-                        <a:t>0.581</a:t>
+                        <a:t>0.588</a:t>
                       </a:r>
                     </a:p>
                   </a:txBody>
@@ -8676,7 +8676,7 @@
                           </a:solidFill>
                           <a:latin typeface="Calibri"/>
                         </a:rPr>
-                        <a:t>0.574</a:t>
+                        <a:t>0.580</a:t>
                       </a:r>
                     </a:p>
                   </a:txBody>
@@ -8699,7 +8699,7 @@
                           </a:solidFill>
                           <a:latin typeface="Calibri"/>
                         </a:rPr>
-                        <a:t>0.631</a:t>
+                        <a:t>0.645</a:t>
                       </a:r>
                     </a:p>
                   </a:txBody>
@@ -8770,7 +8770,7 @@
                           </a:solidFill>
                           <a:latin typeface="Calibri"/>
                         </a:rPr>
-                        <a:t>0.694</a:t>
+                        <a:t>0.695</a:t>
                       </a:r>
                     </a:p>
                   </a:txBody>
@@ -8793,7 +8793,7 @@
                           </a:solidFill>
                           <a:latin typeface="Calibri"/>
                         </a:rPr>
-                        <a:t>0.674</a:t>
+                        <a:t>0.666</a:t>
                       </a:r>
                     </a:p>
                   </a:txBody>
@@ -8816,7 +8816,7 @@
                           </a:solidFill>
                           <a:latin typeface="Calibri"/>
                         </a:rPr>
-                        <a:t>0.754</a:t>
+                        <a:t>0.766</a:t>
                       </a:r>
                     </a:p>
                   </a:txBody>
@@ -8982,7 +8982,7 @@
                 </a:solidFill>
                 <a:latin typeface="Calibri"/>
               </a:rPr>
-              <a:t>"Yes — combining modalities substantially improves emotion recognition"</a:t>
+              <a:t>"Yes - combining modalities substantially improves emotion recognition"</a:t>
             </a:r>
           </a:p>
         </p:txBody>
@@ -9238,7 +9238,7 @@
                 </a:solidFill>
                 <a:latin typeface="Calibri"/>
               </a:rPr>
-              <a:t>Macro F1 = 0.7104   ·   +0.059 over text-only   ·   no additional training required</a:t>
+              <a:t>Macro F1 = 0.7108   ·   +0.063 over text-only   ·   no additional training required</a:t>
             </a:r>
           </a:p>
         </p:txBody>
@@ -9304,7 +9304,7 @@
                 </a:solidFill>
                 <a:latin typeface="Calibri"/>
               </a:rPr>
-              <a:t>Text and audio each reach ~0.64–0.65 Macro F1 alone — comparable, but limited.</a:t>
+              <a:t>Text and audio each reach ~0.64–0.65 Macro F1 alone - comparable, but limited.</a:t>
             </a:r>
           </a:p>
         </p:txBody>
@@ -9436,7 +9436,7 @@
                 </a:solidFill>
                 <a:latin typeface="Calibri"/>
               </a:rPr>
-              <a:t>Late fusion: Macro F1 = 0.71 — +0.06 gain, zero training overhead.</a:t>
+              <a:t>Late fusion: Macro F1 = 0.71 - +0.06 gain, zero training overhead.</a:t>
             </a:r>
           </a:p>
         </p:txBody>
@@ -9502,7 +9502,7 @@
                 </a:solidFill>
                 <a:latin typeface="Calibri"/>
               </a:rPr>
-              <a:t>Hardest class: 0.48/0.51 → 0.55. Absence of signal becomes a signal.</a:t>
+              <a:t>Hardest class: 0.46/0.51 → 0.55. Absence of signal becomes a signal.</a:t>
             </a:r>
           </a:p>
         </p:txBody>
@@ -9693,7 +9693,7 @@
                 </a:solidFill>
                 <a:latin typeface="Calibri"/>
               </a:rPr>
-              <a:t>Appendix A2 — Full Per-Class Breakdown  (show during Q&amp;A)</a:t>
+              <a:t>Appendix A2 - Full Per-Class Breakdown  (show during Q&amp;A)</a:t>
             </a:r>
           </a:p>
         </p:txBody>
@@ -9967,7 +9967,7 @@
                           </a:solidFill>
                           <a:latin typeface="Calibri"/>
                         </a:rPr>
-                        <a:t>RoBERTa — Negative</a:t>
+                        <a:t>RoBERTa - Negative</a:t>
                       </a:r>
                     </a:p>
                   </a:txBody>
@@ -9990,7 +9990,7 @@
                           </a:solidFill>
                           <a:latin typeface="Calibri"/>
                         </a:rPr>
-                        <a:t>0.80</a:t>
+                        <a:t>0.81</a:t>
                       </a:r>
                     </a:p>
                   </a:txBody>
@@ -10013,7 +10013,7 @@
                           </a:solidFill>
                           <a:latin typeface="Calibri"/>
                         </a:rPr>
-                        <a:t>0.73</a:t>
+                        <a:t>0.72</a:t>
                       </a:r>
                     </a:p>
                   </a:txBody>
@@ -10059,7 +10059,7 @@
                           </a:solidFill>
                           <a:latin typeface="Calibri"/>
                         </a:rPr>
-                        <a:t>1193</a:t>
+                        <a:t>1149</a:t>
                       </a:r>
                     </a:p>
                   </a:txBody>
@@ -10084,7 +10084,7 @@
                           </a:solidFill>
                           <a:latin typeface="Calibri"/>
                         </a:rPr>
-                        <a:t>RoBERTa — Positive</a:t>
+                        <a:t>RoBERTa - Positive</a:t>
                       </a:r>
                     </a:p>
                   </a:txBody>
@@ -10107,7 +10107,7 @@
                           </a:solidFill>
                           <a:latin typeface="Calibri"/>
                         </a:rPr>
-                        <a:t>0.75</a:t>
+                        <a:t>0.73</a:t>
                       </a:r>
                     </a:p>
                   </a:txBody>
@@ -10130,7 +10130,7 @@
                           </a:solidFill>
                           <a:latin typeface="Calibri"/>
                         </a:rPr>
-                        <a:t>0.68</a:t>
+                        <a:t>0.70</a:t>
                       </a:r>
                     </a:p>
                   </a:txBody>
@@ -10153,7 +10153,7 @@
                           </a:solidFill>
                           <a:latin typeface="Calibri"/>
                         </a:rPr>
-                        <a:t>0.71</a:t>
+                        <a:t>0.72</a:t>
                       </a:r>
                     </a:p>
                   </a:txBody>
@@ -10176,7 +10176,7 @@
                           </a:solidFill>
                           <a:latin typeface="Calibri"/>
                         </a:rPr>
-                        <a:t> 585</a:t>
+                        <a:t> 613</a:t>
                       </a:r>
                     </a:p>
                   </a:txBody>
@@ -10201,7 +10201,7 @@
                           </a:solidFill>
                           <a:latin typeface="Calibri"/>
                         </a:rPr>
-                        <a:t>RoBERTa — Neutral</a:t>
+                        <a:t>RoBERTa - Neutral</a:t>
                       </a:r>
                     </a:p>
                   </a:txBody>
@@ -10224,7 +10224,7 @@
                           </a:solidFill>
                           <a:latin typeface="Calibri"/>
                         </a:rPr>
-                        <a:t>0.39</a:t>
+                        <a:t>0.40</a:t>
                       </a:r>
                     </a:p>
                   </a:txBody>
@@ -10247,7 +10247,7 @@
                           </a:solidFill>
                           <a:latin typeface="Calibri"/>
                         </a:rPr>
-                        <a:t>0.66</a:t>
+                        <a:t>0.54</a:t>
                       </a:r>
                     </a:p>
                   </a:txBody>
@@ -10270,7 +10270,7 @@
                           </a:solidFill>
                           <a:latin typeface="Calibri"/>
                         </a:rPr>
-                        <a:t>0.48</a:t>
+                        <a:t>0.46</a:t>
                       </a:r>
                     </a:p>
                   </a:txBody>
@@ -10293,7 +10293,7 @@
                           </a:solidFill>
                           <a:latin typeface="Calibri"/>
                         </a:rPr>
-                        <a:t> 392</a:t>
+                        <a:t> 408</a:t>
                       </a:r>
                     </a:p>
                   </a:txBody>
@@ -10318,7 +10318,521 @@
                           </a:solidFill>
                           <a:latin typeface="Calibri"/>
                         </a:rPr>
-                        <a:t>Wav2Vec2 — Negative</a:t>
+                        <a:t>Wav2Vec2 - Negative</a:t>
+                      </a:r>
+                    </a:p>
+                  </a:txBody>
+                  <a:tcPr>
+                    <a:solidFill>
+                      <a:srgbClr val="E8EDF3"/>
+                    </a:solidFill>
+                  </a:tcPr>
+                </a:tc>
+                <a:tc>
+                  <a:txBody>
+                    <a:bodyPr/>
+                    <a:lstStyle/>
+                    <a:p>
+                      <a:pPr algn="ctr"/>
+                      <a:r>
+                        <a:rPr sz="1200">
+                          <a:solidFill>
+                            <a:srgbClr val="1A202C"/>
+                          </a:solidFill>
+                          <a:latin typeface="Calibri"/>
+                        </a:rPr>
+                        <a:t>0.80</a:t>
+                      </a:r>
+                    </a:p>
+                  </a:txBody>
+                  <a:tcPr>
+                    <a:solidFill>
+                      <a:srgbClr val="E8EDF3"/>
+                    </a:solidFill>
+                  </a:tcPr>
+                </a:tc>
+                <a:tc>
+                  <a:txBody>
+                    <a:bodyPr/>
+                    <a:lstStyle/>
+                    <a:p>
+                      <a:pPr algn="ctr"/>
+                      <a:r>
+                        <a:rPr sz="1200">
+                          <a:solidFill>
+                            <a:srgbClr val="1A202C"/>
+                          </a:solidFill>
+                          <a:latin typeface="Calibri"/>
+                        </a:rPr>
+                        <a:t>0.77</a:t>
+                      </a:r>
+                    </a:p>
+                  </a:txBody>
+                  <a:tcPr>
+                    <a:solidFill>
+                      <a:srgbClr val="E8EDF3"/>
+                    </a:solidFill>
+                  </a:tcPr>
+                </a:tc>
+                <a:tc>
+                  <a:txBody>
+                    <a:bodyPr/>
+                    <a:lstStyle/>
+                    <a:p>
+                      <a:pPr algn="ctr"/>
+                      <a:r>
+                        <a:rPr sz="1200">
+                          <a:solidFill>
+                            <a:srgbClr val="1A202C"/>
+                          </a:solidFill>
+                          <a:latin typeface="Calibri"/>
+                        </a:rPr>
+                        <a:t>0.78</a:t>
+                      </a:r>
+                    </a:p>
+                  </a:txBody>
+                  <a:tcPr>
+                    <a:solidFill>
+                      <a:srgbClr val="E8EDF3"/>
+                    </a:solidFill>
+                  </a:tcPr>
+                </a:tc>
+                <a:tc>
+                  <a:txBody>
+                    <a:bodyPr/>
+                    <a:lstStyle/>
+                    <a:p>
+                      <a:pPr algn="ctr"/>
+                      <a:r>
+                        <a:rPr sz="1200">
+                          <a:solidFill>
+                            <a:srgbClr val="1A202C"/>
+                          </a:solidFill>
+                          <a:latin typeface="Calibri"/>
+                        </a:rPr>
+                        <a:t>1149</a:t>
+                      </a:r>
+                    </a:p>
+                  </a:txBody>
+                  <a:tcPr>
+                    <a:solidFill>
+                      <a:srgbClr val="E8EDF3"/>
+                    </a:solidFill>
+                  </a:tcPr>
+                </a:tc>
+              </a:tr>
+              <a:tr h="420624">
+                <a:tc>
+                  <a:txBody>
+                    <a:bodyPr/>
+                    <a:lstStyle/>
+                    <a:p>
+                      <a:pPr algn="ctr"/>
+                      <a:r>
+                        <a:rPr sz="1200">
+                          <a:solidFill>
+                            <a:srgbClr val="1A202C"/>
+                          </a:solidFill>
+                          <a:latin typeface="Calibri"/>
+                        </a:rPr>
+                        <a:t>Wav2Vec2 - Positive</a:t>
+                      </a:r>
+                    </a:p>
+                  </a:txBody>
+                  <a:tcPr>
+                    <a:solidFill>
+                      <a:srgbClr val="F0F4F8"/>
+                    </a:solidFill>
+                  </a:tcPr>
+                </a:tc>
+                <a:tc>
+                  <a:txBody>
+                    <a:bodyPr/>
+                    <a:lstStyle/>
+                    <a:p>
+                      <a:pPr algn="ctr"/>
+                      <a:r>
+                        <a:rPr sz="1200">
+                          <a:solidFill>
+                            <a:srgbClr val="1A202C"/>
+                          </a:solidFill>
+                          <a:latin typeface="Calibri"/>
+                        </a:rPr>
+                        <a:t>0.68</a:t>
+                      </a:r>
+                    </a:p>
+                  </a:txBody>
+                  <a:tcPr>
+                    <a:solidFill>
+                      <a:srgbClr val="F0F4F8"/>
+                    </a:solidFill>
+                  </a:tcPr>
+                </a:tc>
+                <a:tc>
+                  <a:txBody>
+                    <a:bodyPr/>
+                    <a:lstStyle/>
+                    <a:p>
+                      <a:pPr algn="ctr"/>
+                      <a:r>
+                        <a:rPr sz="1200">
+                          <a:solidFill>
+                            <a:srgbClr val="1A202C"/>
+                          </a:solidFill>
+                          <a:latin typeface="Calibri"/>
+                        </a:rPr>
+                        <a:t>0.59</a:t>
+                      </a:r>
+                    </a:p>
+                  </a:txBody>
+                  <a:tcPr>
+                    <a:solidFill>
+                      <a:srgbClr val="F0F4F8"/>
+                    </a:solidFill>
+                  </a:tcPr>
+                </a:tc>
+                <a:tc>
+                  <a:txBody>
+                    <a:bodyPr/>
+                    <a:lstStyle/>
+                    <a:p>
+                      <a:pPr algn="ctr"/>
+                      <a:r>
+                        <a:rPr sz="1200">
+                          <a:solidFill>
+                            <a:srgbClr val="1A202C"/>
+                          </a:solidFill>
+                          <a:latin typeface="Calibri"/>
+                        </a:rPr>
+                        <a:t>0.63</a:t>
+                      </a:r>
+                    </a:p>
+                  </a:txBody>
+                  <a:tcPr>
+                    <a:solidFill>
+                      <a:srgbClr val="F0F4F8"/>
+                    </a:solidFill>
+                  </a:tcPr>
+                </a:tc>
+                <a:tc>
+                  <a:txBody>
+                    <a:bodyPr/>
+                    <a:lstStyle/>
+                    <a:p>
+                      <a:pPr algn="ctr"/>
+                      <a:r>
+                        <a:rPr sz="1200">
+                          <a:solidFill>
+                            <a:srgbClr val="1A202C"/>
+                          </a:solidFill>
+                          <a:latin typeface="Calibri"/>
+                        </a:rPr>
+                        <a:t> 613</a:t>
+                      </a:r>
+                    </a:p>
+                  </a:txBody>
+                  <a:tcPr>
+                    <a:solidFill>
+                      <a:srgbClr val="F0F4F8"/>
+                    </a:solidFill>
+                  </a:tcPr>
+                </a:tc>
+              </a:tr>
+              <a:tr h="420624">
+                <a:tc>
+                  <a:txBody>
+                    <a:bodyPr/>
+                    <a:lstStyle/>
+                    <a:p>
+                      <a:pPr algn="ctr"/>
+                      <a:r>
+                        <a:rPr sz="1200">
+                          <a:solidFill>
+                            <a:srgbClr val="1A202C"/>
+                          </a:solidFill>
+                          <a:latin typeface="Calibri"/>
+                        </a:rPr>
+                        <a:t>Wav2Vec2 - Neutral</a:t>
+                      </a:r>
+                    </a:p>
+                  </a:txBody>
+                  <a:tcPr>
+                    <a:solidFill>
+                      <a:srgbClr val="E8EDF3"/>
+                    </a:solidFill>
+                  </a:tcPr>
+                </a:tc>
+                <a:tc>
+                  <a:txBody>
+                    <a:bodyPr/>
+                    <a:lstStyle/>
+                    <a:p>
+                      <a:pPr algn="ctr"/>
+                      <a:r>
+                        <a:rPr sz="1200">
+                          <a:solidFill>
+                            <a:srgbClr val="1A202C"/>
+                          </a:solidFill>
+                          <a:latin typeface="Calibri"/>
+                        </a:rPr>
+                        <a:t>0.45</a:t>
+                      </a:r>
+                    </a:p>
+                  </a:txBody>
+                  <a:tcPr>
+                    <a:solidFill>
+                      <a:srgbClr val="E8EDF3"/>
+                    </a:solidFill>
+                  </a:tcPr>
+                </a:tc>
+                <a:tc>
+                  <a:txBody>
+                    <a:bodyPr/>
+                    <a:lstStyle/>
+                    <a:p>
+                      <a:pPr algn="ctr"/>
+                      <a:r>
+                        <a:rPr sz="1200">
+                          <a:solidFill>
+                            <a:srgbClr val="1A202C"/>
+                          </a:solidFill>
+                          <a:latin typeface="Calibri"/>
+                        </a:rPr>
+                        <a:t>0.58</a:t>
+                      </a:r>
+                    </a:p>
+                  </a:txBody>
+                  <a:tcPr>
+                    <a:solidFill>
+                      <a:srgbClr val="E8EDF3"/>
+                    </a:solidFill>
+                  </a:tcPr>
+                </a:tc>
+                <a:tc>
+                  <a:txBody>
+                    <a:bodyPr/>
+                    <a:lstStyle/>
+                    <a:p>
+                      <a:pPr algn="ctr"/>
+                      <a:r>
+                        <a:rPr sz="1200">
+                          <a:solidFill>
+                            <a:srgbClr val="1A202C"/>
+                          </a:solidFill>
+                          <a:latin typeface="Calibri"/>
+                        </a:rPr>
+                        <a:t>0.51</a:t>
+                      </a:r>
+                    </a:p>
+                  </a:txBody>
+                  <a:tcPr>
+                    <a:solidFill>
+                      <a:srgbClr val="E8EDF3"/>
+                    </a:solidFill>
+                  </a:tcPr>
+                </a:tc>
+                <a:tc>
+                  <a:txBody>
+                    <a:bodyPr/>
+                    <a:lstStyle/>
+                    <a:p>
+                      <a:pPr algn="ctr"/>
+                      <a:r>
+                        <a:rPr sz="1200">
+                          <a:solidFill>
+                            <a:srgbClr val="1A202C"/>
+                          </a:solidFill>
+                          <a:latin typeface="Calibri"/>
+                        </a:rPr>
+                        <a:t> 408</a:t>
+                      </a:r>
+                    </a:p>
+                  </a:txBody>
+                  <a:tcPr>
+                    <a:solidFill>
+                      <a:srgbClr val="E8EDF3"/>
+                    </a:solidFill>
+                  </a:tcPr>
+                </a:tc>
+              </a:tr>
+              <a:tr h="420624">
+                <a:tc>
+                  <a:txBody>
+                    <a:bodyPr/>
+                    <a:lstStyle/>
+                    <a:p>
+                      <a:pPr algn="ctr"/>
+                      <a:r>
+                        <a:rPr sz="1200">
+                          <a:solidFill>
+                            <a:srgbClr val="1A202C"/>
+                          </a:solidFill>
+                          <a:latin typeface="Calibri"/>
+                        </a:rPr>
+                        <a:t>Fusion (best α=0.45) - Negative</a:t>
+                      </a:r>
+                    </a:p>
+                  </a:txBody>
+                  <a:tcPr>
+                    <a:solidFill>
+                      <a:srgbClr val="F0F4F8"/>
+                    </a:solidFill>
+                  </a:tcPr>
+                </a:tc>
+                <a:tc>
+                  <a:txBody>
+                    <a:bodyPr/>
+                    <a:lstStyle/>
+                    <a:p>
+                      <a:pPr algn="ctr"/>
+                      <a:r>
+                        <a:rPr sz="1200">
+                          <a:solidFill>
+                            <a:srgbClr val="1A202C"/>
+                          </a:solidFill>
+                          <a:latin typeface="Calibri"/>
+                        </a:rPr>
+                        <a:t>0.84</a:t>
+                      </a:r>
+                    </a:p>
+                  </a:txBody>
+                  <a:tcPr>
+                    <a:solidFill>
+                      <a:srgbClr val="F0F4F8"/>
+                    </a:solidFill>
+                  </a:tcPr>
+                </a:tc>
+                <a:tc>
+                  <a:txBody>
+                    <a:bodyPr/>
+                    <a:lstStyle/>
+                    <a:p>
+                      <a:pPr algn="ctr"/>
+                      <a:r>
+                        <a:rPr sz="1200">
+                          <a:solidFill>
+                            <a:srgbClr val="1A202C"/>
+                          </a:solidFill>
+                          <a:latin typeface="Calibri"/>
+                        </a:rPr>
+                        <a:t>0.81</a:t>
+                      </a:r>
+                    </a:p>
+                  </a:txBody>
+                  <a:tcPr>
+                    <a:solidFill>
+                      <a:srgbClr val="F0F4F8"/>
+                    </a:solidFill>
+                  </a:tcPr>
+                </a:tc>
+                <a:tc>
+                  <a:txBody>
+                    <a:bodyPr/>
+                    <a:lstStyle/>
+                    <a:p>
+                      <a:pPr algn="ctr"/>
+                      <a:r>
+                        <a:rPr sz="1200">
+                          <a:solidFill>
+                            <a:srgbClr val="1A202C"/>
+                          </a:solidFill>
+                          <a:latin typeface="Calibri"/>
+                        </a:rPr>
+                        <a:t>0.82</a:t>
+                      </a:r>
+                    </a:p>
+                  </a:txBody>
+                  <a:tcPr>
+                    <a:solidFill>
+                      <a:srgbClr val="F0F4F8"/>
+                    </a:solidFill>
+                  </a:tcPr>
+                </a:tc>
+                <a:tc>
+                  <a:txBody>
+                    <a:bodyPr/>
+                    <a:lstStyle/>
+                    <a:p>
+                      <a:pPr algn="ctr"/>
+                      <a:r>
+                        <a:rPr sz="1200">
+                          <a:solidFill>
+                            <a:srgbClr val="1A202C"/>
+                          </a:solidFill>
+                          <a:latin typeface="Calibri"/>
+                        </a:rPr>
+                        <a:t>1149</a:t>
+                      </a:r>
+                    </a:p>
+                  </a:txBody>
+                  <a:tcPr>
+                    <a:solidFill>
+                      <a:srgbClr val="F0F4F8"/>
+                    </a:solidFill>
+                  </a:tcPr>
+                </a:tc>
+              </a:tr>
+              <a:tr h="420624">
+                <a:tc>
+                  <a:txBody>
+                    <a:bodyPr/>
+                    <a:lstStyle/>
+                    <a:p>
+                      <a:pPr algn="ctr"/>
+                      <a:r>
+                        <a:rPr sz="1200">
+                          <a:solidFill>
+                            <a:srgbClr val="1A202C"/>
+                          </a:solidFill>
+                          <a:latin typeface="Calibri"/>
+                        </a:rPr>
+                        <a:t>Fusion (best α=0.45) - Positive</a:t>
+                      </a:r>
+                    </a:p>
+                  </a:txBody>
+                  <a:tcPr>
+                    <a:solidFill>
+                      <a:srgbClr val="E8EDF3"/>
+                    </a:solidFill>
+                  </a:tcPr>
+                </a:tc>
+                <a:tc>
+                  <a:txBody>
+                    <a:bodyPr/>
+                    <a:lstStyle/>
+                    <a:p>
+                      <a:pPr algn="ctr"/>
+                      <a:r>
+                        <a:rPr sz="1200">
+                          <a:solidFill>
+                            <a:srgbClr val="1A202C"/>
+                          </a:solidFill>
+                          <a:latin typeface="Calibri"/>
+                        </a:rPr>
+                        <a:t>0.78</a:t>
+                      </a:r>
+                    </a:p>
+                  </a:txBody>
+                  <a:tcPr>
+                    <a:solidFill>
+                      <a:srgbClr val="E8EDF3"/>
+                    </a:solidFill>
+                  </a:tcPr>
+                </a:tc>
+                <a:tc>
+                  <a:txBody>
+                    <a:bodyPr/>
+                    <a:lstStyle/>
+                    <a:p>
+                      <a:pPr algn="ctr"/>
+                      <a:r>
+                        <a:rPr sz="1200">
+                          <a:solidFill>
+                            <a:srgbClr val="1A202C"/>
+                          </a:solidFill>
+                          <a:latin typeface="Calibri"/>
+                        </a:rPr>
+                        <a:t>0.74</a:t>
                       </a:r>
                     </a:p>
                   </a:txBody>
@@ -10364,53 +10878,7 @@
                           </a:solidFill>
                           <a:latin typeface="Calibri"/>
                         </a:rPr>
-                        <a:t>0.80</a:t>
-                      </a:r>
-                    </a:p>
-                  </a:txBody>
-                  <a:tcPr>
-                    <a:solidFill>
-                      <a:srgbClr val="E8EDF3"/>
-                    </a:solidFill>
-                  </a:tcPr>
-                </a:tc>
-                <a:tc>
-                  <a:txBody>
-                    <a:bodyPr/>
-                    <a:lstStyle/>
-                    <a:p>
-                      <a:pPr algn="ctr"/>
-                      <a:r>
-                        <a:rPr sz="1200">
-                          <a:solidFill>
-                            <a:srgbClr val="1A202C"/>
-                          </a:solidFill>
-                          <a:latin typeface="Calibri"/>
-                        </a:rPr>
-                        <a:t>0.78</a:t>
-                      </a:r>
-                    </a:p>
-                  </a:txBody>
-                  <a:tcPr>
-                    <a:solidFill>
-                      <a:srgbClr val="E8EDF3"/>
-                    </a:solidFill>
-                  </a:tcPr>
-                </a:tc>
-                <a:tc>
-                  <a:txBody>
-                    <a:bodyPr/>
-                    <a:lstStyle/>
-                    <a:p>
-                      <a:pPr algn="ctr"/>
-                      <a:r>
-                        <a:rPr sz="1200">
-                          <a:solidFill>
-                            <a:srgbClr val="1A202C"/>
-                          </a:solidFill>
-                          <a:latin typeface="Calibri"/>
-                        </a:rPr>
-                        <a:t>1193</a:t>
+                        <a:t> 613</a:t>
                       </a:r>
                     </a:p>
                   </a:txBody>
@@ -10435,7 +10903,7 @@
                           </a:solidFill>
                           <a:latin typeface="Calibri"/>
                         </a:rPr>
-                        <a:t>Wav2Vec2 — Positive</a:t>
+                        <a:t>Fusion (best α=0.45) - Neutral</a:t>
                       </a:r>
                     </a:p>
                   </a:txBody>
@@ -10458,7 +10926,7 @@
                           </a:solidFill>
                           <a:latin typeface="Calibri"/>
                         </a:rPr>
-                        <a:t>0.72</a:t>
+                        <a:t>0.51</a:t>
                       </a:r>
                     </a:p>
                   </a:txBody>
@@ -10481,475 +10949,7 @@
                           </a:solidFill>
                           <a:latin typeface="Calibri"/>
                         </a:rPr>
-                        <a:t>0.56</a:t>
-                      </a:r>
-                    </a:p>
-                  </a:txBody>
-                  <a:tcPr>
-                    <a:solidFill>
-                      <a:srgbClr val="F0F4F8"/>
-                    </a:solidFill>
-                  </a:tcPr>
-                </a:tc>
-                <a:tc>
-                  <a:txBody>
-                    <a:bodyPr/>
-                    <a:lstStyle/>
-                    <a:p>
-                      <a:pPr algn="ctr"/>
-                      <a:r>
-                        <a:rPr sz="1200">
-                          <a:solidFill>
-                            <a:srgbClr val="1A202C"/>
-                          </a:solidFill>
-                          <a:latin typeface="Calibri"/>
-                        </a:rPr>
-                        <a:t>0.63</a:t>
-                      </a:r>
-                    </a:p>
-                  </a:txBody>
-                  <a:tcPr>
-                    <a:solidFill>
-                      <a:srgbClr val="F0F4F8"/>
-                    </a:solidFill>
-                  </a:tcPr>
-                </a:tc>
-                <a:tc>
-                  <a:txBody>
-                    <a:bodyPr/>
-                    <a:lstStyle/>
-                    <a:p>
-                      <a:pPr algn="ctr"/>
-                      <a:r>
-                        <a:rPr sz="1200">
-                          <a:solidFill>
-                            <a:srgbClr val="1A202C"/>
-                          </a:solidFill>
-                          <a:latin typeface="Calibri"/>
-                        </a:rPr>
-                        <a:t> 585</a:t>
-                      </a:r>
-                    </a:p>
-                  </a:txBody>
-                  <a:tcPr>
-                    <a:solidFill>
-                      <a:srgbClr val="F0F4F8"/>
-                    </a:solidFill>
-                  </a:tcPr>
-                </a:tc>
-              </a:tr>
-              <a:tr h="420624">
-                <a:tc>
-                  <a:txBody>
-                    <a:bodyPr/>
-                    <a:lstStyle/>
-                    <a:p>
-                      <a:pPr algn="ctr"/>
-                      <a:r>
-                        <a:rPr sz="1200">
-                          <a:solidFill>
-                            <a:srgbClr val="1A202C"/>
-                          </a:solidFill>
-                          <a:latin typeface="Calibri"/>
-                        </a:rPr>
-                        <a:t>Wav2Vec2 — Neutral</a:t>
-                      </a:r>
-                    </a:p>
-                  </a:txBody>
-                  <a:tcPr>
-                    <a:solidFill>
-                      <a:srgbClr val="E8EDF3"/>
-                    </a:solidFill>
-                  </a:tcPr>
-                </a:tc>
-                <a:tc>
-                  <a:txBody>
-                    <a:bodyPr/>
-                    <a:lstStyle/>
-                    <a:p>
-                      <a:pPr algn="ctr"/>
-                      <a:r>
-                        <a:rPr sz="1200">
-                          <a:solidFill>
-                            <a:srgbClr val="1A202C"/>
-                          </a:solidFill>
-                          <a:latin typeface="Calibri"/>
-                        </a:rPr>
-                        <a:t>0.50</a:t>
-                      </a:r>
-                    </a:p>
-                  </a:txBody>
-                  <a:tcPr>
-                    <a:solidFill>
-                      <a:srgbClr val="E8EDF3"/>
-                    </a:solidFill>
-                  </a:tcPr>
-                </a:tc>
-                <a:tc>
-                  <a:txBody>
-                    <a:bodyPr/>
-                    <a:lstStyle/>
-                    <a:p>
-                      <a:pPr algn="ctr"/>
-                      <a:r>
-                        <a:rPr sz="1200">
-                          <a:solidFill>
-                            <a:srgbClr val="1A202C"/>
-                          </a:solidFill>
-                          <a:latin typeface="Calibri"/>
-                        </a:rPr>
-                        <a:t>0.53</a:t>
-                      </a:r>
-                    </a:p>
-                  </a:txBody>
-                  <a:tcPr>
-                    <a:solidFill>
-                      <a:srgbClr val="E8EDF3"/>
-                    </a:solidFill>
-                  </a:tcPr>
-                </a:tc>
-                <a:tc>
-                  <a:txBody>
-                    <a:bodyPr/>
-                    <a:lstStyle/>
-                    <a:p>
-                      <a:pPr algn="ctr"/>
-                      <a:r>
-                        <a:rPr sz="1200">
-                          <a:solidFill>
-                            <a:srgbClr val="1A202C"/>
-                          </a:solidFill>
-                          <a:latin typeface="Calibri"/>
-                        </a:rPr>
-                        <a:t>0.51</a:t>
-                      </a:r>
-                    </a:p>
-                  </a:txBody>
-                  <a:tcPr>
-                    <a:solidFill>
-                      <a:srgbClr val="E8EDF3"/>
-                    </a:solidFill>
-                  </a:tcPr>
-                </a:tc>
-                <a:tc>
-                  <a:txBody>
-                    <a:bodyPr/>
-                    <a:lstStyle/>
-                    <a:p>
-                      <a:pPr algn="ctr"/>
-                      <a:r>
-                        <a:rPr sz="1200">
-                          <a:solidFill>
-                            <a:srgbClr val="1A202C"/>
-                          </a:solidFill>
-                          <a:latin typeface="Calibri"/>
-                        </a:rPr>
-                        <a:t> 392</a:t>
-                      </a:r>
-                    </a:p>
-                  </a:txBody>
-                  <a:tcPr>
-                    <a:solidFill>
-                      <a:srgbClr val="E8EDF3"/>
-                    </a:solidFill>
-                  </a:tcPr>
-                </a:tc>
-              </a:tr>
-              <a:tr h="420624">
-                <a:tc>
-                  <a:txBody>
-                    <a:bodyPr/>
-                    <a:lstStyle/>
-                    <a:p>
-                      <a:pPr algn="ctr"/>
-                      <a:r>
-                        <a:rPr sz="1200">
-                          <a:solidFill>
-                            <a:srgbClr val="1A202C"/>
-                          </a:solidFill>
-                          <a:latin typeface="Calibri"/>
-                        </a:rPr>
-                        <a:t>Fusion — Negative</a:t>
-                      </a:r>
-                    </a:p>
-                  </a:txBody>
-                  <a:tcPr>
-                    <a:solidFill>
-                      <a:srgbClr val="F0F4F8"/>
-                    </a:solidFill>
-                  </a:tcPr>
-                </a:tc>
-                <a:tc>
-                  <a:txBody>
-                    <a:bodyPr/>
-                    <a:lstStyle/>
-                    <a:p>
-                      <a:pPr algn="ctr"/>
-                      <a:r>
-                        <a:rPr sz="1200">
-                          <a:solidFill>
-                            <a:srgbClr val="1A202C"/>
-                          </a:solidFill>
-                          <a:latin typeface="Calibri"/>
-                        </a:rPr>
-                        <a:t>0.83</a:t>
-                      </a:r>
-                    </a:p>
-                  </a:txBody>
-                  <a:tcPr>
-                    <a:solidFill>
-                      <a:srgbClr val="F0F4F8"/>
-                    </a:solidFill>
-                  </a:tcPr>
-                </a:tc>
-                <a:tc>
-                  <a:txBody>
-                    <a:bodyPr/>
-                    <a:lstStyle/>
-                    <a:p>
-                      <a:pPr algn="ctr"/>
-                      <a:r>
-                        <a:rPr sz="1200">
-                          <a:solidFill>
-                            <a:srgbClr val="1A202C"/>
-                          </a:solidFill>
-                          <a:latin typeface="Calibri"/>
-                        </a:rPr>
-                        <a:t>0.80</a:t>
-                      </a:r>
-                    </a:p>
-                  </a:txBody>
-                  <a:tcPr>
-                    <a:solidFill>
-                      <a:srgbClr val="F0F4F8"/>
-                    </a:solidFill>
-                  </a:tcPr>
-                </a:tc>
-                <a:tc>
-                  <a:txBody>
-                    <a:bodyPr/>
-                    <a:lstStyle/>
-                    <a:p>
-                      <a:pPr algn="ctr"/>
-                      <a:r>
-                        <a:rPr sz="1200">
-                          <a:solidFill>
-                            <a:srgbClr val="1A202C"/>
-                          </a:solidFill>
-                          <a:latin typeface="Calibri"/>
-                        </a:rPr>
-                        <a:t>0.81</a:t>
-                      </a:r>
-                    </a:p>
-                  </a:txBody>
-                  <a:tcPr>
-                    <a:solidFill>
-                      <a:srgbClr val="F0F4F8"/>
-                    </a:solidFill>
-                  </a:tcPr>
-                </a:tc>
-                <a:tc>
-                  <a:txBody>
-                    <a:bodyPr/>
-                    <a:lstStyle/>
-                    <a:p>
-                      <a:pPr algn="ctr"/>
-                      <a:r>
-                        <a:rPr sz="1200">
-                          <a:solidFill>
-                            <a:srgbClr val="1A202C"/>
-                          </a:solidFill>
-                          <a:latin typeface="Calibri"/>
-                        </a:rPr>
-                        <a:t>1193</a:t>
-                      </a:r>
-                    </a:p>
-                  </a:txBody>
-                  <a:tcPr>
-                    <a:solidFill>
-                      <a:srgbClr val="F0F4F8"/>
-                    </a:solidFill>
-                  </a:tcPr>
-                </a:tc>
-              </a:tr>
-              <a:tr h="420624">
-                <a:tc>
-                  <a:txBody>
-                    <a:bodyPr/>
-                    <a:lstStyle/>
-                    <a:p>
-                      <a:pPr algn="ctr"/>
-                      <a:r>
-                        <a:rPr sz="1200">
-                          <a:solidFill>
-                            <a:srgbClr val="1A202C"/>
-                          </a:solidFill>
-                          <a:latin typeface="Calibri"/>
-                        </a:rPr>
-                        <a:t>Fusion — Positive</a:t>
-                      </a:r>
-                    </a:p>
-                  </a:txBody>
-                  <a:tcPr>
-                    <a:solidFill>
-                      <a:srgbClr val="E8EDF3"/>
-                    </a:solidFill>
-                  </a:tcPr>
-                </a:tc>
-                <a:tc>
-                  <a:txBody>
-                    <a:bodyPr/>
-                    <a:lstStyle/>
-                    <a:p>
-                      <a:pPr algn="ctr"/>
-                      <a:r>
-                        <a:rPr sz="1200">
-                          <a:solidFill>
-                            <a:srgbClr val="1A202C"/>
-                          </a:solidFill>
-                          <a:latin typeface="Calibri"/>
-                        </a:rPr>
-                        <a:t>0.79</a:t>
-                      </a:r>
-                    </a:p>
-                  </a:txBody>
-                  <a:tcPr>
-                    <a:solidFill>
-                      <a:srgbClr val="E8EDF3"/>
-                    </a:solidFill>
-                  </a:tcPr>
-                </a:tc>
-                <a:tc>
-                  <a:txBody>
-                    <a:bodyPr/>
-                    <a:lstStyle/>
-                    <a:p>
-                      <a:pPr algn="ctr"/>
-                      <a:r>
-                        <a:rPr sz="1200">
-                          <a:solidFill>
-                            <a:srgbClr val="1A202C"/>
-                          </a:solidFill>
-                          <a:latin typeface="Calibri"/>
-                        </a:rPr>
-                        <a:t>0.71</a:t>
-                      </a:r>
-                    </a:p>
-                  </a:txBody>
-                  <a:tcPr>
-                    <a:solidFill>
-                      <a:srgbClr val="E8EDF3"/>
-                    </a:solidFill>
-                  </a:tcPr>
-                </a:tc>
-                <a:tc>
-                  <a:txBody>
-                    <a:bodyPr/>
-                    <a:lstStyle/>
-                    <a:p>
-                      <a:pPr algn="ctr"/>
-                      <a:r>
-                        <a:rPr sz="1200">
-                          <a:solidFill>
-                            <a:srgbClr val="1A202C"/>
-                          </a:solidFill>
-                          <a:latin typeface="Calibri"/>
-                        </a:rPr>
-                        <a:t>0.75</a:t>
-                      </a:r>
-                    </a:p>
-                  </a:txBody>
-                  <a:tcPr>
-                    <a:solidFill>
-                      <a:srgbClr val="E8EDF3"/>
-                    </a:solidFill>
-                  </a:tcPr>
-                </a:tc>
-                <a:tc>
-                  <a:txBody>
-                    <a:bodyPr/>
-                    <a:lstStyle/>
-                    <a:p>
-                      <a:pPr algn="ctr"/>
-                      <a:r>
-                        <a:rPr sz="1200">
-                          <a:solidFill>
-                            <a:srgbClr val="1A202C"/>
-                          </a:solidFill>
-                          <a:latin typeface="Calibri"/>
-                        </a:rPr>
-                        <a:t> 585</a:t>
-                      </a:r>
-                    </a:p>
-                  </a:txBody>
-                  <a:tcPr>
-                    <a:solidFill>
-                      <a:srgbClr val="E8EDF3"/>
-                    </a:solidFill>
-                  </a:tcPr>
-                </a:tc>
-              </a:tr>
-              <a:tr h="420624">
-                <a:tc>
-                  <a:txBody>
-                    <a:bodyPr/>
-                    <a:lstStyle/>
-                    <a:p>
-                      <a:pPr algn="ctr"/>
-                      <a:r>
-                        <a:rPr sz="1200">
-                          <a:solidFill>
-                            <a:srgbClr val="1A202C"/>
-                          </a:solidFill>
-                          <a:latin typeface="Calibri"/>
-                        </a:rPr>
-                        <a:t>Fusion — Neutral</a:t>
-                      </a:r>
-                    </a:p>
-                  </a:txBody>
-                  <a:tcPr>
-                    <a:solidFill>
-                      <a:srgbClr val="F0F4F8"/>
-                    </a:solidFill>
-                  </a:tcPr>
-                </a:tc>
-                <a:tc>
-                  <a:txBody>
-                    <a:bodyPr/>
-                    <a:lstStyle/>
-                    <a:p>
-                      <a:pPr algn="ctr"/>
-                      <a:r>
-                        <a:rPr sz="1200">
-                          <a:solidFill>
-                            <a:srgbClr val="1A202C"/>
-                          </a:solidFill>
-                          <a:latin typeface="Calibri"/>
-                        </a:rPr>
-                        <a:t>0.52</a:t>
-                      </a:r>
-                    </a:p>
-                  </a:txBody>
-                  <a:tcPr>
-                    <a:solidFill>
-                      <a:srgbClr val="F0F4F8"/>
-                    </a:solidFill>
-                  </a:tcPr>
-                </a:tc>
-                <a:tc>
-                  <a:txBody>
-                    <a:bodyPr/>
-                    <a:lstStyle/>
-                    <a:p>
-                      <a:pPr algn="ctr"/>
-                      <a:r>
-                        <a:rPr sz="1200">
-                          <a:solidFill>
-                            <a:srgbClr val="1A202C"/>
-                          </a:solidFill>
-                          <a:latin typeface="Calibri"/>
-                        </a:rPr>
-                        <a:t>0.58</a:t>
+                        <a:t>0.60</a:t>
                       </a:r>
                     </a:p>
                   </a:txBody>
@@ -10995,7 +10995,7 @@
                           </a:solidFill>
                           <a:latin typeface="Calibri"/>
                         </a:rPr>
-                        <a:t> 392</a:t>
+                        <a:t> 408</a:t>
                       </a:r>
                     </a:p>
                   </a:txBody>
@@ -11109,7 +11109,7 @@
                 </a:solidFill>
                 <a:latin typeface="Calibri"/>
               </a:rPr>
-              <a:t>Appendix A3 — Hyperparameter Summary  (show during Q&amp;A)</a:t>
+              <a:t>Appendix A3 - Hyperparameter Summary  (show during Q&amp;A)</a:t>
             </a:r>
           </a:p>
         </p:txBody>
@@ -11642,7 +11642,7 @@
                           </a:solidFill>
                           <a:latin typeface="Calibri"/>
                         </a:rPr>
-                        <a:t>7</a:t>
+                        <a:t>10</a:t>
                       </a:r>
                     </a:p>
                   </a:txBody>
@@ -11665,7 +11665,7 @@
                           </a:solidFill>
                           <a:latin typeface="Calibri"/>
                         </a:rPr>
-                        <a:t>10</a:t>
+                        <a:t>8</a:t>
                       </a:r>
                     </a:p>
                   </a:txBody>
@@ -13095,7 +13095,7 @@
                 </a:solidFill>
                 <a:latin typeface="Calibri"/>
               </a:rPr>
-              <a:t>Every sample has both modalities — ideal for comparing text-only, audio-only, and combined.</a:t>
+              <a:t>Every sample has both modalities - ideal for comparing text-only, audio-only, and combined.</a:t>
             </a:r>
           </a:p>
         </p:txBody>
@@ -13199,7 +13199,7 @@
                 </a:solidFill>
                 <a:latin typeface="Calibri"/>
               </a:rPr>
-              <a:t>We grouped 10 emotions into 3 classes — and found severe class imbalance</a:t>
+              <a:t>We grouped 10 emotions into 3 classes - and found severe class imbalance</a:t>
             </a:r>
           </a:p>
         </p:txBody>
@@ -13875,7 +13875,7 @@
                 </a:solidFill>
                 <a:latin typeface="Calibri"/>
               </a:rPr>
-              <a:t>Audio captures AROUSAL — angry &amp; excited speech has clearly higher pitch and energy</a:t>
+              <a:t>Audio captures AROUSAL - angry &amp; excited speech has clearly higher pitch and energy</a:t>
             </a:r>
           </a:p>
         </p:txBody>
@@ -13929,7 +13929,7 @@
                 </a:solidFill>
                 <a:latin typeface="Calibri"/>
               </a:rPr>
-              <a:t>Text captures VALENCE — distinguishing happy vs. angry requires understanding the words</a:t>
+              <a:t>Text captures VALENCE - distinguishing happy vs. angry requires understanding the words</a:t>
             </a:r>
           </a:p>
         </p:txBody>
@@ -14276,7 +14276,7 @@
                 </a:solidFill>
                 <a:latin typeface="Calibri"/>
               </a:rPr>
-              <a:t>No missing values — no cleaning needed</a:t>
+              <a:t>No missing values - no cleaning needed</a:t>
             </a:r>
           </a:p>
           <a:p>
@@ -14587,7 +14587,7 @@
                 </a:solidFill>
                 <a:latin typeface="Calibri"/>
               </a:rPr>
-              <a:t>TEST  — Session 5  ✦</a:t>
+              <a:t>TEST  - Session 5  ✦</a:t>
             </a:r>
           </a:p>
           <a:p>
@@ -14706,7 +14706,7 @@
                 </a:solidFill>
                 <a:latin typeface="Calibri"/>
               </a:rPr>
-              <a:t>✦  Speaker-independent evaluation — the hardest and most honest test of generalization.</a:t>
+              <a:t>✦  Speaker-independent evaluation - the hardest and most honest test of generalization.</a:t>
             </a:r>
           </a:p>
         </p:txBody>
@@ -14810,7 +14810,7 @@
                 </a:solidFill>
                 <a:latin typeface="Calibri"/>
               </a:rPr>
-              <a:t>Model 1: RoBERTa reads the words and achieves Macro F1 = 0.6519</a:t>
+              <a:t>Model 1: RoBERTa reads the words and achieves Macro F1 = 0.6475</a:t>
             </a:r>
           </a:p>
         </p:txBody>
@@ -15025,7 +15025,7 @@
                 </a:solidFill>
                 <a:latin typeface="Calibri"/>
               </a:rPr>
-              <a:t>Pre-training:  MLM on 160 GB text — already understands that 'infuriating' is negative</a:t>
+              <a:t>Pre-training:  MLM on 160 GB text - already understands that 'infuriating' is negative</a:t>
             </a:r>
           </a:p>
           <a:p>
@@ -15097,7 +15097,7 @@
                 </a:solidFill>
                 <a:latin typeface="Calibri"/>
               </a:rPr>
-              <a:t>Best checkpoint:  epoch 4 of 7  (early stopping on val Macro F1)</a:t>
+              <a:t>Best checkpoint:  epoch 7 of 10  (early stopping on val Macro F1)</a:t>
             </a:r>
           </a:p>
           <a:p>
@@ -15122,20 +15122,72 @@
                 <a:latin typeface="Calibri"/>
               </a:rPr>
               <a:t>Weakness:  Neutral has no distinctive words → text alone struggles</a:t>
+            </a:r>
+          </a:p>
+        </p:txBody>
+      </p:sp>
+      <p:sp>
+        <p:nvSpPr>
+          <p:cNvPr id="9" name="Rectangle 8"/>
+          <p:cNvSpPr/>
+          <p:nvPr/>
+        </p:nvSpPr>
+        <p:spPr>
+          <a:xfrm>
+            <a:off x="457200" y="5596128"/>
+            <a:ext cx="11274552" cy="621792"/>
+          </a:xfrm>
+          <a:prstGeom prst="rect">
+            <a:avLst/>
+          </a:prstGeom>
+          <a:solidFill>
+            <a:srgbClr val="1E3659"/>
+          </a:solidFill>
+          <a:ln>
+            <a:noFill/>
+          </a:ln>
+        </p:spPr>
+        <p:style>
+          <a:lnRef idx="1">
+            <a:schemeClr val="accent1"/>
+          </a:lnRef>
+          <a:fillRef idx="3">
+            <a:schemeClr val="accent1"/>
+          </a:fillRef>
+          <a:effectRef idx="2">
+            <a:schemeClr val="accent1"/>
+          </a:effectRef>
+          <a:fontRef idx="minor">
+            <a:schemeClr val="lt1"/>
+          </a:fontRef>
+        </p:style>
+        <p:txBody>
+          <a:bodyPr rtlCol="0" anchor="ctr" wrap="square" lIns="109728" rIns="109728" tIns="73152" bIns="73152"/>
+          <a:lstStyle/>
+          <a:p>
+            <a:pPr algn="ctr"/>
+            <a:r>
+              <a:rPr sz="1400" b="1">
+                <a:solidFill>
+                  <a:srgbClr val="FFFFFF"/>
+                </a:solidFill>
+                <a:latin typeface="Calibri"/>
+              </a:rPr>
+              <a:t>RoBERTa:  Accuracy = 0.6843  ·  Macro F1 = 0.6475  ·  Neutral F1 = 0.46 (weakest class)</a:t>
             </a:r>
           </a:p>
         </p:txBody>
       </p:sp>
       <p:pic>
         <p:nvPicPr>
-          <p:cNvPr id="8" name="Picture 7" descr="roberta_f1.png"/>
+          <p:cNvPr id="10" name="Picture 9" descr="slide7_new.png"/>
           <p:cNvPicPr>
             <a:picLocks noChangeAspect="1"/>
           </p:cNvPicPr>
           <p:nvPr/>
         </p:nvPicPr>
         <p:blipFill>
-          <a:blip r:embed="rId2"/>
+          <a:blip r:embed="rId4"/>
           <a:stretch>
             <a:fillRect/>
           </a:stretch>
@@ -15143,65 +15195,13 @@
         <p:spPr>
           <a:xfrm>
             <a:off x="7040880" y="1293876"/>
-            <a:ext cx="4955858" cy="3931920"/>
+            <a:ext cx="4955858" cy="4002808"/>
           </a:xfrm>
           <a:prstGeom prst="rect">
             <a:avLst/>
           </a:prstGeom>
         </p:spPr>
       </p:pic>
-      <p:sp>
-        <p:nvSpPr>
-          <p:cNvPr id="9" name="Rectangle 8"/>
-          <p:cNvSpPr/>
-          <p:nvPr/>
-        </p:nvSpPr>
-        <p:spPr>
-          <a:xfrm>
-            <a:off x="457200" y="5596128"/>
-            <a:ext cx="11274552" cy="621792"/>
-          </a:xfrm>
-          <a:prstGeom prst="rect">
-            <a:avLst/>
-          </a:prstGeom>
-          <a:solidFill>
-            <a:srgbClr val="1E3659"/>
-          </a:solidFill>
-          <a:ln>
-            <a:noFill/>
-          </a:ln>
-        </p:spPr>
-        <p:style>
-          <a:lnRef idx="1">
-            <a:schemeClr val="accent1"/>
-          </a:lnRef>
-          <a:fillRef idx="3">
-            <a:schemeClr val="accent1"/>
-          </a:fillRef>
-          <a:effectRef idx="2">
-            <a:schemeClr val="accent1"/>
-          </a:effectRef>
-          <a:fontRef idx="minor">
-            <a:schemeClr val="lt1"/>
-          </a:fontRef>
-        </p:style>
-        <p:txBody>
-          <a:bodyPr rtlCol="0" anchor="ctr" wrap="square" lIns="109728" rIns="109728" tIns="73152" bIns="73152"/>
-          <a:lstStyle/>
-          <a:p>
-            <a:pPr algn="ctr"/>
-            <a:r>
-              <a:rPr sz="1400" b="1">
-                <a:solidFill>
-                  <a:srgbClr val="FFFFFF"/>
-                </a:solidFill>
-                <a:latin typeface="Calibri"/>
-              </a:rPr>
-              <a:t>RoBERTa:  Accuracy = 0.6793  ·  Macro F1 = 0.6519  ·  Neutral F1 = 0.48 (weakest class)</a:t>
-            </a:r>
-          </a:p>
-        </p:txBody>
-      </p:sp>
     </p:spTree>
   </p:cSld>
   <p:clrMapOvr>
@@ -15301,7 +15301,7 @@
                 </a:solidFill>
                 <a:latin typeface="Calibri"/>
               </a:rPr>
-              <a:t>Model 2: Wav2Vec2 listens to the audio and achieves Macro F1 = 0.6403</a:t>
+              <a:t>Model 2: Wav2Vec2 listens to the audio and achieves Macro F1 = 0.6398</a:t>
             </a:r>
           </a:p>
         </p:txBody>
@@ -15588,21 +15588,73 @@
                 </a:solidFill>
                 <a:latin typeface="Calibri"/>
               </a:rPr>
-              <a:t>Key finding:  Negative F1 = 0.78 (&gt; RoBERTa's 0.76) — audio is stronger at detecting high-arousal angry/frustrated speech</a:t>
+              <a:t>Key finding:  Negative F1 = 0.78 (&gt; RoBERTa's 0.76) - audio is stronger at detecting high-arousal angry/frustrated speech</a:t>
+            </a:r>
+          </a:p>
+        </p:txBody>
+      </p:sp>
+      <p:sp>
+        <p:nvSpPr>
+          <p:cNvPr id="9" name="Rectangle 8"/>
+          <p:cNvSpPr/>
+          <p:nvPr/>
+        </p:nvSpPr>
+        <p:spPr>
+          <a:xfrm>
+            <a:off x="457200" y="5596128"/>
+            <a:ext cx="11274552" cy="621792"/>
+          </a:xfrm>
+          <a:prstGeom prst="rect">
+            <a:avLst/>
+          </a:prstGeom>
+          <a:solidFill>
+            <a:srgbClr val="1E3659"/>
+          </a:solidFill>
+          <a:ln>
+            <a:noFill/>
+          </a:ln>
+        </p:spPr>
+        <p:style>
+          <a:lnRef idx="1">
+            <a:schemeClr val="accent1"/>
+          </a:lnRef>
+          <a:fillRef idx="3">
+            <a:schemeClr val="accent1"/>
+          </a:fillRef>
+          <a:effectRef idx="2">
+            <a:schemeClr val="accent1"/>
+          </a:effectRef>
+          <a:fontRef idx="minor">
+            <a:schemeClr val="lt1"/>
+          </a:fontRef>
+        </p:style>
+        <p:txBody>
+          <a:bodyPr rtlCol="0" anchor="ctr" wrap="square" lIns="109728" rIns="109728" tIns="73152" bIns="73152"/>
+          <a:lstStyle/>
+          <a:p>
+            <a:pPr algn="ctr"/>
+            <a:r>
+              <a:rPr sz="1400" b="1">
+                <a:solidFill>
+                  <a:srgbClr val="FFFFFF"/>
+                </a:solidFill>
+                <a:latin typeface="Calibri"/>
+              </a:rPr>
+              <a:t>Wav2Vec2:  Accuracy = 0.6829  ·  Macro F1 = 0.6398  ·  Different per-class strengths than text</a:t>
             </a:r>
           </a:p>
         </p:txBody>
       </p:sp>
       <p:pic>
         <p:nvPicPr>
-          <p:cNvPr id="8" name="Picture 7" descr="wav2vec2_f1.png"/>
+          <p:cNvPr id="10" name="Picture 9" descr="slide8_new.png"/>
           <p:cNvPicPr>
             <a:picLocks noChangeAspect="1"/>
           </p:cNvPicPr>
           <p:nvPr/>
         </p:nvPicPr>
         <p:blipFill>
-          <a:blip r:embed="rId2"/>
+          <a:blip r:embed="rId4"/>
           <a:stretch>
             <a:fillRect/>
           </a:stretch>
@@ -15610,65 +15662,13 @@
         <p:spPr>
           <a:xfrm>
             <a:off x="7040880" y="1293876"/>
-            <a:ext cx="4955858" cy="3931920"/>
+            <a:ext cx="4955858" cy="4002808"/>
           </a:xfrm>
           <a:prstGeom prst="rect">
             <a:avLst/>
           </a:prstGeom>
         </p:spPr>
       </p:pic>
-      <p:sp>
-        <p:nvSpPr>
-          <p:cNvPr id="9" name="Rectangle 8"/>
-          <p:cNvSpPr/>
-          <p:nvPr/>
-        </p:nvSpPr>
-        <p:spPr>
-          <a:xfrm>
-            <a:off x="457200" y="5596128"/>
-            <a:ext cx="11274552" cy="621792"/>
-          </a:xfrm>
-          <a:prstGeom prst="rect">
-            <a:avLst/>
-          </a:prstGeom>
-          <a:solidFill>
-            <a:srgbClr val="1E3659"/>
-          </a:solidFill>
-          <a:ln>
-            <a:noFill/>
-          </a:ln>
-        </p:spPr>
-        <p:style>
-          <a:lnRef idx="1">
-            <a:schemeClr val="accent1"/>
-          </a:lnRef>
-          <a:fillRef idx="3">
-            <a:schemeClr val="accent1"/>
-          </a:fillRef>
-          <a:effectRef idx="2">
-            <a:schemeClr val="accent1"/>
-          </a:effectRef>
-          <a:fontRef idx="minor">
-            <a:schemeClr val="lt1"/>
-          </a:fontRef>
-        </p:style>
-        <p:txBody>
-          <a:bodyPr rtlCol="0" anchor="ctr" wrap="square" lIns="109728" rIns="109728" tIns="73152" bIns="73152"/>
-          <a:lstStyle/>
-          <a:p>
-            <a:pPr algn="ctr"/>
-            <a:r>
-              <a:rPr sz="1400" b="1">
-                <a:solidFill>
-                  <a:srgbClr val="FFFFFF"/>
-                </a:solidFill>
-                <a:latin typeface="Calibri"/>
-              </a:rPr>
-              <a:t>Wav2Vec2:  Accuracy = 0.6880  ·  Macro F1 = 0.6403  ·  Different per-class strengths than text</a:t>
-            </a:r>
-          </a:p>
-        </p:txBody>
-      </p:sp>
     </p:spTree>
   </p:cSld>
   <p:clrMapOvr>
@@ -15768,7 +15768,7 @@
                 </a:solidFill>
                 <a:latin typeface="Calibri"/>
               </a:rPr>
-              <a:t>The two models make different mistakes — that is why combining them helps</a:t>
+              <a:t>The two models make different mistakes - that is why combining them helps</a:t>
             </a:r>
           </a:p>
         </p:txBody>
@@ -15947,7 +15947,7 @@
                 </a:solidFill>
                 <a:latin typeface="Calibri"/>
               </a:rPr>
-              <a:t>"I hate everything about this" — said flatly.</a:t>
+              <a:t>"I hate everything about this" - said flatly.</a:t>
             </a:r>
           </a:p>
           <a:p>
@@ -16025,7 +16025,7 @@
                 </a:solidFill>
                 <a:latin typeface="Calibri"/>
               </a:rPr>
-              <a:t>"Fine, whatever." — said with sharp rising anger.</a:t>
+              <a:t>"Fine, whatever." - said with sharp rising anger.</a:t>
             </a:r>
           </a:p>
           <a:p>
@@ -16091,7 +16091,7 @@
                 </a:solidFill>
                 <a:latin typeface="Calibri"/>
               </a:rPr>
-              <a:t>Both ✓ — high confidence</a:t>
+              <a:t>Both ✓ - high confidence</a:t>
             </a:r>
           </a:p>
           <a:p>
@@ -16169,7 +16169,7 @@
                 </a:solidFill>
                 <a:latin typeface="Calibri"/>
               </a:rPr>
-              <a:t>Both ✗ — genuinely ambiguous</a:t>
+              <a:t>Both ✗ - genuinely ambiguous</a:t>
             </a:r>
           </a:p>
           <a:p>
@@ -16193,7 +16193,7 @@
                 </a:solidFill>
                 <a:latin typeface="Calibri"/>
               </a:rPr>
-              <a:t>Not fixable by fusion — an honest failure case.</a:t>
+              <a:t>Not fixable by fusion - an honest failure case.</a:t>
             </a:r>
           </a:p>
         </p:txBody>
@@ -16245,7 +16245,7 @@
                 </a:solidFill>
                 <a:latin typeface="Calibri"/>
               </a:rPr>
-              <a:t>Non-overlapping errors are the condition for fusion to help — and the data shows they are.</a:t>
+              <a:t>Non-overlapping errors are the condition for fusion to help - and the data shows they are.</a:t>
             </a:r>
           </a:p>
         </p:txBody>

</xml_diff>